<commit_message>
Refresh overview deck/doc: add cross-service (microservice) flow
</commit_message>
<xml_diff>
--- a/docs/code-kg-overview.pptx
+++ b/docs/code-kg-overview.pptx
@@ -8,6 +8,7 @@
     <p:sldId id="256" r:id="rId7"/>
     <p:sldId id="257" r:id="rId8"/>
     <p:sldId id="258" r:id="rId9"/>
+    <p:sldId id="259" r:id="rId10"/>
   </p:sldIdLst>
   <p:sldSz cx="12191695" cy="6858000" type="screen4x3"/>
   <p:notesSz cx="6858000" cy="9144000"/>
@@ -3120,7 +3121,7 @@
         <p:spPr>
           <a:xfrm>
             <a:off x="640080" y="1737360"/>
-            <a:ext cx="10972800" cy="4754880"/>
+            <a:ext cx="10972800" cy="4937760"/>
           </a:xfrm>
           <a:prstGeom prst="rect">
             <a:avLst/>
@@ -3172,21 +3173,21 @@
             <a:pPr lvl="1"/>
             <a:r>
               <a:rPr sz="1800" b="0"/>
-              <a:t>Built deterministically (tree-sitter + Spring/JPA annotations), stored in local SQLite, served to agents over MCP.</a:t>
+              <a:t>Deterministic build (tree-sitter + Spring/JPA annotations) -&gt; local SQLite -&gt; served to agents over MCP.</a:t>
             </a:r>
           </a:p>
           <a:p>
             <a:pPr lvl="1"/>
             <a:r>
               <a:rPr sz="1800" b="0"/>
-              <a:t>Optional LLM enrichment (Azure OpenAI) adds a feature→files map — constrained so it can only reference symbols that already exist (no hallucinated files).</a:t>
+              <a:t>Optional LLM enrichment (Azure OpenAI) adds a feature-&gt;files map, constrained to existing symbols (no hallucinated files).</a:t>
             </a:r>
           </a:p>
           <a:p>
             <a:pPr lvl="1"/>
             <a:r>
               <a:rPr sz="1800" b="1"/>
-              <a:t>Scope: Java / Spring Boot / Hibernate (Spring Data JPA).</a:t>
+              <a:t>Scope: Java / Spring Boot / Hibernate (Spring Data JPA), and multi-service flow via federation.</a:t>
             </a:r>
           </a:p>
         </p:txBody>
@@ -3239,7 +3240,7 @@
         <p:spPr>
           <a:xfrm>
             <a:off x="640080" y="1554480"/>
-            <a:ext cx="10972800" cy="4754880"/>
+            <a:ext cx="10972800" cy="4937760"/>
           </a:xfrm>
           <a:prstGeom prst="rect">
             <a:avLst/>
@@ -3254,49 +3255,56 @@
           <a:p>
             <a:pPr/>
             <a:r>
-              <a:rPr sz="1700" b="0"/>
-              <a:t>[1] Extractor (tree-sitter)  →  nodes (class/method/field) + edges (calls, imports, extends, implements)</a:t>
+              <a:rPr sz="1600" b="0"/>
+              <a:t>[1] Extractor (tree-sitter)  -&gt;  nodes (class/method/field) + edges (calls, imports, extends, implements)</a:t>
             </a:r>
           </a:p>
           <a:p>
             <a:pPr/>
             <a:r>
-              <a:rPr sz="1700" b="0"/>
-              <a:t>[2] Spring pass  →  endpoints (@GetMapping + class @RequestMapping prefix), DI 'injects' edges, layer classification</a:t>
+              <a:rPr sz="1600" b="0"/>
+              <a:t>[2] Spring pass  -&gt;  endpoints (@GetMapping + class @RequestMapping prefix), DI 'injects' edges, layers</a:t>
             </a:r>
           </a:p>
           <a:p>
             <a:pPr/>
             <a:r>
-              <a:rPr sz="1700" b="0"/>
-              <a:t>[2b] JPA / Hibernate pass  →  @Entity + table, relationships with cascade / fetch / mappedBy / owning side / @JoinColumn, JpaRepository→entity ('persists')</a:t>
+              <a:rPr sz="1600" b="0"/>
+              <a:t>[2b] JPA / Hibernate pass  -&gt;  @Entity + table, relationships (cascade/fetch/mappedBy/owning/@JoinColumn), JpaRepository-&gt;entity</a:t>
             </a:r>
           </a:p>
           <a:p>
             <a:pPr/>
             <a:r>
-              <a:rPr sz="1700" b="0"/>
-              <a:t>[3] Enrichment (Azure OpenAI, optional)  →  feature→files map; anti-hallucination gate rejects unknown nodes/files</a:t>
+              <a:rPr sz="1600" b="0"/>
+              <a:t>[2c] Outbound pass  -&gt;  Feign + RestTemplate calls to other services ('calls_service')</a:t>
             </a:r>
           </a:p>
           <a:p>
             <a:pPr/>
             <a:r>
-              <a:rPr sz="1700" b="0"/>
-              <a:t>[4] MCP server  →  agents query the graph via kg_* tools</a:t>
+              <a:rPr sz="1600" b="0"/>
+              <a:t>[3] Enrichment (Azure OpenAI, optional)  -&gt;  feature-&gt;files map; anti-hallucination gate rejects unknown nodes/files</a:t>
             </a:r>
           </a:p>
           <a:p>
             <a:pPr/>
             <a:r>
-              <a:rPr sz="1700" b="0"/>
-              <a:t>[5] Sync  →  index (full) / reindex (incremental, detects changed files)</a:t>
+              <a:rPr sz="1600" b="0"/>
+              <a:t>[4] MCP server  -&gt;  agents query the graph via kg_* tools</a:t>
             </a:r>
           </a:p>
           <a:p>
             <a:pPr/>
             <a:r>
-              <a:rPr sz="1700" b="1">
+              <a:rPr sz="1600" b="0"/>
+              <a:t>[5] Sync / Federate  -&gt;  index (full) / reindex (incremental); federate merges services + links cross-service calls</a:t>
+            </a:r>
+          </a:p>
+          <a:p>
+            <a:pPr/>
+            <a:r>
+              <a:rPr sz="1600" b="1">
                 <a:solidFill>
                   <a:srgbClr val="2E6F9E"/>
                 </a:solidFill>
@@ -3307,8 +3315,8 @@
           <a:p>
             <a:pPr/>
             <a:r>
-              <a:rPr sz="1600" b="0"/>
-              <a:t>Schema: nodes(...attrs) · edges(src,dst,kind,attrs) · features · feature_files</a:t>
+              <a:rPr sz="1500" b="0"/>
+              <a:t>Schema: nodes(...attrs, service) | edges(src, dst, kind, attrs) | features | feature_files</a:t>
             </a:r>
           </a:p>
         </p:txBody>
@@ -3361,7 +3369,7 @@
         <p:spPr>
           <a:xfrm>
             <a:off x="640080" y="1554480"/>
-            <a:ext cx="10972800" cy="4754880"/>
+            <a:ext cx="10972800" cy="4937760"/>
           </a:xfrm>
           <a:prstGeom prst="rect">
             <a:avLst/>
@@ -3387,8 +3395,8 @@
           <a:p>
             <a:pPr lvl="1"/>
             <a:r>
-              <a:rPr sz="1600" b="0"/>
-              <a:t>kg_architecture · kg_find_files_for_feature · kg_endpoints/kg_endpoint · kg_callers/kg_callees · kg_impact_of · kg_data_model/kg_entity · kg_neighbors/kg_describe</a:t>
+              <a:rPr sz="1500" b="0"/>
+              <a:t>kg_architecture | kg_find_files_for_feature | kg_endpoints/kg_endpoint | kg_callers/kg_callees | kg_impact_of | kg_data_model/kg_entity | kg_service_map/kg_request_flow | kg_neighbors/kg_describe</a:t>
             </a:r>
           </a:p>
           <a:p>
@@ -3399,14 +3407,14 @@
                   <a:srgbClr val="2E6F9E"/>
                 </a:solidFill>
               </a:rPr>
-              <a:t>CLI</a:t>
+              <a:t>CLI (run via uv)</a:t>
             </a:r>
           </a:p>
           <a:p>
             <a:pPr lvl="1"/>
             <a:r>
-              <a:rPr sz="1600" b="0"/>
-              <a:t>code-kg  index | reindex | enrich | serve | digest   (run via uv)</a:t>
+              <a:rPr sz="1500" b="0"/>
+              <a:t>code-kg  index | reindex | enrich | serve | digest | federate</a:t>
             </a:r>
           </a:p>
           <a:p>
@@ -3423,8 +3431,8 @@
           <a:p>
             <a:pPr lvl="1"/>
             <a:r>
-              <a:rPr sz="1600" b="0"/>
-              <a:t>Spring DI 'injects' edges, feature→files map, and deep JPA/Hibernate mapping (cascade/fetch/mappedBy/join columns) — not just call graphs and routes.</a:t>
+              <a:rPr sz="1500" b="0"/>
+              <a:t>Spring DI 'injects' edges, feature-&gt;files map, deep JPA/Hibernate mapping, and cross-service request flow - beyond call graphs and routes.</a:t>
             </a:r>
           </a:p>
           <a:p>
@@ -3441,8 +3449,130 @@
           <a:p>
             <a:pPr lvl="1"/>
             <a:r>
-              <a:rPr sz="1600" b="0"/>
-              <a:t>Python + uv · tree-sitter / tree-sitter-java · SQLite · FastMCP (mcp[cli]) · Azure OpenAI (optional enrichment)</a:t>
+              <a:rPr sz="1500" b="0"/>
+              <a:t>Python + uv | tree-sitter / tree-sitter-java | SQLite | FastMCP (mcp[cli]) | Azure OpenAI (optional enrichment)</a:t>
+            </a:r>
+          </a:p>
+        </p:txBody>
+      </p:sp>
+    </p:spTree>
+  </p:cSld>
+  <p:clrMapOvr>
+    <a:masterClrMapping/>
+  </p:clrMapOvr>
+</p:sld>
+</file>
+
+<file path=ppt/slides/slide4.xml><?xml version="1.0" encoding="utf-8"?>
+<p:sld xmlns:a="http://schemas.openxmlformats.org/drawingml/2006/main" xmlns:p="http://schemas.openxmlformats.org/presentationml/2006/main" xmlns:r="http://schemas.openxmlformats.org/officeDocument/2006/relationships">
+  <p:cSld>
+    <p:spTree>
+      <p:nvGrpSpPr>
+        <p:cNvPr id="1" name=""/>
+        <p:cNvGrpSpPr/>
+        <p:nvPr/>
+      </p:nvGrpSpPr>
+      <p:grpSpPr/>
+      <p:sp>
+        <p:nvSpPr>
+          <p:cNvPr id="2" name="Title 1"/>
+          <p:cNvSpPr>
+            <a:spLocks noGrp="1"/>
+          </p:cNvSpPr>
+          <p:nvPr>
+            <p:ph type="title"/>
+          </p:nvPr>
+        </p:nvSpPr>
+        <p:spPr/>
+        <p:txBody>
+          <a:bodyPr/>
+          <a:lstStyle/>
+          <a:p>
+            <a:r>
+              <a:t>Microservices: Cross-Service Flow</a:t>
+            </a:r>
+          </a:p>
+        </p:txBody>
+      </p:sp>
+      <p:sp>
+        <p:nvSpPr>
+          <p:cNvPr id="3" name="TextBox 2"/>
+          <p:cNvSpPr txBox="1"/>
+          <p:nvPr/>
+        </p:nvSpPr>
+        <p:spPr>
+          <a:xfrm>
+            <a:off x="640080" y="1554480"/>
+            <a:ext cx="10972800" cy="4937760"/>
+          </a:xfrm>
+          <a:prstGeom prst="rect">
+            <a:avLst/>
+          </a:prstGeom>
+          <a:noFill/>
+        </p:spPr>
+        <p:txBody>
+          <a:bodyPr wrap="square">
+            <a:spAutoFit/>
+          </a:bodyPr>
+          <a:lstStyle/>
+          <a:p>
+            <a:pPr/>
+            <a:r>
+              <a:rPr sz="1800" b="1"/>
+              <a:t>Index each service independently (order-independent), then federate to link them.</a:t>
+            </a:r>
+          </a:p>
+          <a:p>
+            <a:pPr/>
+            <a:r>
+              <a:rPr sz="1700" b="0"/>
+              <a:t>Outbound calls detected per service: OpenFeign (@FeignClient) and RestTemplate (http://&lt;service&gt;/&lt;path&gt;).</a:t>
+            </a:r>
+          </a:p>
+          <a:p>
+            <a:pPr/>
+            <a:r>
+              <a:rPr sz="1700" b="0"/>
+              <a:t>federate merges per-service graphs (node ids namespaced &lt;service&gt;::) and matches each outbound call to the called service's real endpoint, linking them with a 'calls_remote' edge.</a:t>
+            </a:r>
+          </a:p>
+          <a:p>
+            <a:pPr/>
+            <a:r>
+              <a:rPr sz="1700" b="1">
+                <a:solidFill>
+                  <a:srgbClr val="2E6F9E"/>
+                </a:solidFill>
+              </a:rPr>
+              <a:t>One federated MCP exposes ALL services' indexes PLUS the cross-service links.</a:t>
+            </a:r>
+          </a:p>
+          <a:p>
+            <a:pPr/>
+            <a:r>
+              <a:rPr sz="1700" b="0"/>
+              <a:t>kg_service_map()  -&gt;  which service calls which (resolved vs unresolved).</a:t>
+            </a:r>
+          </a:p>
+          <a:p>
+            <a:pPr/>
+            <a:r>
+              <a:rPr sz="1700" b="0"/>
+              <a:t>kg_request_flow('/users/register')  -&gt;  traces the request across service boundaries.</a:t>
+            </a:r>
+          </a:p>
+          <a:p>
+            <a:pPr/>
+            <a:r>
+              <a:rPr sz="1700" b="0"/>
+              <a:t>kg_impact_of  -&gt;  impact analysis now spans services.</a:t>
+            </a:r>
+          </a:p>
+          <a:p>
+            <a:pPr/>
+            <a:r>
+              <a:rPr sz="1500" b="0"/>
+              <a:t>Contract: a Feign name / RestTemplate host must equal the called service's --service name; unmatched calls show as unresolved.</a:t>
             </a:r>
           </a:p>
         </p:txBody>

</xml_diff>

<commit_message>
Enrich: also generate per-node one-line summaries
The enrichment pass now asks the model for a one-line summary per class /
endpoint handler in addition to the feature map, and writes them to
nodes.summary via the same anti-hallucination gate (unknown node ids rejected).
Summaries surface through kg_describe / kg_find_files_for_feature.

- enrich.py: request + write summaries; report summaries_written/rejected
- cli.py: enrich command reports summary counts
- tests: summary surfaces via kg_describe (30 passing)
- docs: refresh PPTX/DOCX to note per-node summaries
</commit_message>
<xml_diff>
--- a/docs/code-kg-overview.pptx
+++ b/docs/code-kg-overview.pptx
@@ -3180,7 +3180,7 @@
             <a:pPr lvl="1"/>
             <a:r>
               <a:rPr sz="1800" b="0"/>
-              <a:t>Optional LLM enrichment (Azure OpenAI) adds a feature-&gt;files map, constrained to existing symbols (no hallucinated files).</a:t>
+              <a:t>Optional LLM enrichment (Azure OpenAI) adds a feature-&gt;files map AND per-class/endpoint one-line summaries, constrained to existing symbols (no hallucinated files).</a:t>
             </a:r>
           </a:p>
           <a:p>
@@ -3284,7 +3284,7 @@
             <a:pPr/>
             <a:r>
               <a:rPr sz="1600" b="0"/>
-              <a:t>[3] Enrichment (Azure OpenAI, optional)  -&gt;  feature-&gt;files map; anti-hallucination gate rejects unknown nodes/files</a:t>
+              <a:t>[3] Enrichment (Azure OpenAI, optional)  -&gt;  feature-&gt;files map + per-node summaries; anti-hallucination gate rejects unknown nodes/files</a:t>
             </a:r>
           </a:p>
           <a:p>

</xml_diff>